<commit_message>
Removed Indic QA bench from comparison table
</commit_message>
<xml_diff>
--- a/Milestone Files/Milestone 1/Milestone 1 Presentation.pptx
+++ b/Milestone Files/Milestone 1/Milestone 1 Presentation.pptx
@@ -12,7 +12,7 @@
     <p:sldId id="256" r:id="rId3"/>
     <p:sldId id="257" r:id="rId4"/>
     <p:sldId id="258" r:id="rId5"/>
-    <p:sldId id="259" r:id="rId6"/>
+    <p:sldId id="264" r:id="rId6"/>
     <p:sldId id="260" r:id="rId7"/>
     <p:sldId id="261" r:id="rId8"/>
   </p:sldIdLst>
@@ -116,6 +116,57 @@
     </p:ext>
   </p:extLst>
 </p:presentation>
+</file>
+
+<file path=ppt/revisionInfo.xml><?xml version="1.0" encoding="utf-8"?>
+<p1510:revInfo xmlns:a="http://schemas.openxmlformats.org/drawingml/2006/main" xmlns:r="http://schemas.openxmlformats.org/officeDocument/2006/relationships" xmlns:p1510="http://schemas.microsoft.com/office/powerpoint/2015/10/main">
+  <p1510:revLst>
+    <p1510:client id="{F47D9511-C09A-443C-9D06-A19EF58B87E1}" v="1" dt="2026-07-04T17:48:20.455"/>
+  </p1510:revLst>
+</p1510:revInfo>
+</file>
+
+<file path=ppt/changesInfos/changesInfo1.xml><?xml version="1.0" encoding="utf-8"?>
+<pc:chgInfo xmlns:a="http://schemas.openxmlformats.org/drawingml/2006/main" xmlns:r="http://schemas.openxmlformats.org/officeDocument/2006/relationships" xmlns:ac="http://schemas.microsoft.com/office/drawing/2013/main/command" xmlns:pc="http://schemas.microsoft.com/office/powerpoint/2013/main/command">
+  <pc:docChgLst>
+    <pc:chgData name="Hitesh Binjrawat" userId="dd94bfdbcf3b553c" providerId="LiveId" clId="{DEC7D341-F93A-42D7-932B-4BCD881941E7}"/>
+    <pc:docChg chg="addSld delSld modSld sldOrd">
+      <pc:chgData name="Hitesh Binjrawat" userId="dd94bfdbcf3b553c" providerId="LiveId" clId="{DEC7D341-F93A-42D7-932B-4BCD881941E7}" dt="2026-07-04T17:48:43.481" v="6" actId="20577"/>
+      <pc:docMkLst>
+        <pc:docMk/>
+      </pc:docMkLst>
+      <pc:sldChg chg="del">
+        <pc:chgData name="Hitesh Binjrawat" userId="dd94bfdbcf3b553c" providerId="LiveId" clId="{DEC7D341-F93A-42D7-932B-4BCD881941E7}" dt="2026-07-04T17:48:29.118" v="5" actId="47"/>
+        <pc:sldMkLst>
+          <pc:docMk/>
+          <pc:sldMk cId="0" sldId="259"/>
+        </pc:sldMkLst>
+      </pc:sldChg>
+      <pc:sldChg chg="new del">
+        <pc:chgData name="Hitesh Binjrawat" userId="dd94bfdbcf3b553c" providerId="LiveId" clId="{DEC7D341-F93A-42D7-932B-4BCD881941E7}" dt="2026-07-04T17:48:23.885" v="2" actId="47"/>
+        <pc:sldMkLst>
+          <pc:docMk/>
+          <pc:sldMk cId="3154884169" sldId="263"/>
+        </pc:sldMkLst>
+      </pc:sldChg>
+      <pc:sldChg chg="modSp add mod ord setBg">
+        <pc:chgData name="Hitesh Binjrawat" userId="dd94bfdbcf3b553c" providerId="LiveId" clId="{DEC7D341-F93A-42D7-932B-4BCD881941E7}" dt="2026-07-04T17:48:43.481" v="6" actId="20577"/>
+        <pc:sldMkLst>
+          <pc:docMk/>
+          <pc:sldMk cId="0" sldId="264"/>
+        </pc:sldMkLst>
+        <pc:spChg chg="mod">
+          <ac:chgData name="Hitesh Binjrawat" userId="dd94bfdbcf3b553c" providerId="LiveId" clId="{DEC7D341-F93A-42D7-932B-4BCD881941E7}" dt="2026-07-04T17:48:43.481" v="6" actId="20577"/>
+          <ac:spMkLst>
+            <pc:docMk/>
+            <pc:sldMk cId="0" sldId="264"/>
+            <ac:spMk id="7" creationId="{00000000-0000-0000-0000-000000000000}"/>
+          </ac:spMkLst>
+        </pc:spChg>
+      </pc:sldChg>
+    </pc:docChg>
+  </pc:docChgLst>
+</pc:chgInfo>
 </file>
 
 <file path=ppt/notesMasters/notesMaster1.xml><?xml version="1.0" encoding="utf-8"?>
@@ -3418,15 +3469,7 @@
 
 <file path=ppt/slides/slide5.xml><?xml version="1.0" encoding="utf-8"?>
 <p:sld xmlns:a="http://schemas.openxmlformats.org/drawingml/2006/main" xmlns:r="http://schemas.openxmlformats.org/officeDocument/2006/relationships" xmlns:p="http://schemas.openxmlformats.org/presentationml/2006/main">
-  <p:cSld name="Slide 4">
-    <p:bg>
-      <p:bgPr>
-        <a:solidFill>
-          <a:srgbClr val="F7F7FB"/>
-        </a:solidFill>
-        <a:effectLst/>
-      </p:bgPr>
-    </p:bg>
+  <p:cSld>
     <p:spTree>
       <p:nvGrpSpPr>
         <p:cNvPr id="1" name=""/>
@@ -3525,17 +3568,11 @@
           <p:cNvGraphicFramePr>
             <a:graphicFrameLocks noGrp="1"/>
           </p:cNvGraphicFramePr>
-          <p:nvPr>
-            <p:extLst>
-              <p:ext uri="{D42A27DB-BD31-4B8C-83A1-F6EECF244321}">
-                <p14:modId xmlns:p14="http://schemas.microsoft.com/office/powerpoint/2010/main" val="1579011935"/>
-              </p:ext>
-            </p:extLst>
-          </p:nvPr>
+          <p:nvPr/>
         </p:nvGraphicFramePr>
         <p:xfrm>
           <a:off x="548640" y="1508760"/>
-          <a:ext cx="11064240" cy="3657600"/>
+          <a:ext cx="11064240" cy="2880360"/>
         </p:xfrm>
         <a:graphic>
           <a:graphicData uri="http://schemas.openxmlformats.org/drawingml/2006/table">
@@ -4522,317 +4559,6 @@
                         <a:buNone/>
                       </a:pPr>
                       <a:r>
-                        <a:rPr lang="en-US" sz="1150" dirty="0">
-                          <a:solidFill>
-                            <a:srgbClr val="2A2E4A"/>
-                          </a:solidFill>
-                        </a:rPr>
-                        <a:t>IndicQA Benchmark</a:t>
-                      </a:r>
-                      <a:endParaRPr lang="en-US" sz="1150" dirty="0"/>
-                    </a:p>
-                    <a:p>
-                      <a:pPr marL="0" indent="0">
-                        <a:buNone/>
-                      </a:pPr>
-                      <a:r>
-                        <a:rPr lang="en-US" sz="1150" dirty="0">
-                          <a:solidFill>
-                            <a:srgbClr val="2A2E4A"/>
-                          </a:solidFill>
-                        </a:rPr>
-                        <a:t>(Singh et al. 2024)</a:t>
-                      </a:r>
-                      <a:endParaRPr lang="en-US" sz="1150" dirty="0"/>
-                    </a:p>
-                  </a:txBody>
-                  <a:tcPr anchor="ctr">
-                    <a:lnL w="9525" cap="flat" cmpd="sng" algn="ctr">
-                      <a:solidFill>
-                        <a:srgbClr val="D8DAE8"/>
-                      </a:solidFill>
-                      <a:prstDash val="solid"/>
-                      <a:round/>
-                      <a:headEnd type="none" w="med" len="med"/>
-                      <a:tailEnd type="none" w="med" len="med"/>
-                    </a:lnL>
-                    <a:lnR w="9525" cap="flat" cmpd="sng" algn="ctr">
-                      <a:solidFill>
-                        <a:srgbClr val="D8DAE8"/>
-                      </a:solidFill>
-                      <a:prstDash val="solid"/>
-                      <a:round/>
-                      <a:headEnd type="none" w="med" len="med"/>
-                      <a:tailEnd type="none" w="med" len="med"/>
-                    </a:lnR>
-                    <a:lnT w="9525" cap="flat" cmpd="sng" algn="ctr">
-                      <a:solidFill>
-                        <a:srgbClr val="D8DAE8"/>
-                      </a:solidFill>
-                      <a:prstDash val="solid"/>
-                      <a:round/>
-                      <a:headEnd type="none" w="med" len="med"/>
-                      <a:tailEnd type="none" w="med" len="med"/>
-                    </a:lnT>
-                    <a:lnB w="9525" cap="flat" cmpd="sng" algn="ctr">
-                      <a:solidFill>
-                        <a:srgbClr val="D8DAE8"/>
-                      </a:solidFill>
-                      <a:prstDash val="solid"/>
-                      <a:round/>
-                      <a:headEnd type="none" w="med" len="med"/>
-                      <a:tailEnd type="none" w="med" len="med"/>
-                    </a:lnB>
-                  </a:tcPr>
-                </a:tc>
-                <a:tc>
-                  <a:txBody>
-                    <a:bodyPr/>
-                    <a:lstStyle/>
-                    <a:p>
-                      <a:pPr marL="0" indent="0">
-                        <a:buNone/>
-                      </a:pPr>
-                      <a:r>
-                        <a:rPr lang="en-US" sz="1150" dirty="0">
-                          <a:solidFill>
-                            <a:srgbClr val="2A2E4A"/>
-                          </a:solidFill>
-                        </a:rPr>
-                        <a:t>11-language Indic QA evaluation suite</a:t>
-                      </a:r>
-                      <a:endParaRPr lang="en-US" sz="1150" dirty="0"/>
-                    </a:p>
-                  </a:txBody>
-                  <a:tcPr anchor="ctr">
-                    <a:lnL w="9525" cap="flat" cmpd="sng" algn="ctr">
-                      <a:solidFill>
-                        <a:srgbClr val="D8DAE8"/>
-                      </a:solidFill>
-                      <a:prstDash val="solid"/>
-                      <a:round/>
-                      <a:headEnd type="none" w="med" len="med"/>
-                      <a:tailEnd type="none" w="med" len="med"/>
-                    </a:lnL>
-                    <a:lnR w="9525" cap="flat" cmpd="sng" algn="ctr">
-                      <a:solidFill>
-                        <a:srgbClr val="D8DAE8"/>
-                      </a:solidFill>
-                      <a:prstDash val="solid"/>
-                      <a:round/>
-                      <a:headEnd type="none" w="med" len="med"/>
-                      <a:tailEnd type="none" w="med" len="med"/>
-                    </a:lnR>
-                    <a:lnT w="9525" cap="flat" cmpd="sng" algn="ctr">
-                      <a:solidFill>
-                        <a:srgbClr val="D8DAE8"/>
-                      </a:solidFill>
-                      <a:prstDash val="solid"/>
-                      <a:round/>
-                      <a:headEnd type="none" w="med" len="med"/>
-                      <a:tailEnd type="none" w="med" len="med"/>
-                    </a:lnT>
-                    <a:lnB w="9525" cap="flat" cmpd="sng" algn="ctr">
-                      <a:solidFill>
-                        <a:srgbClr val="D8DAE8"/>
-                      </a:solidFill>
-                      <a:prstDash val="solid"/>
-                      <a:round/>
-                      <a:headEnd type="none" w="med" len="med"/>
-                      <a:tailEnd type="none" w="med" len="med"/>
-                    </a:lnB>
-                  </a:tcPr>
-                </a:tc>
-                <a:tc>
-                  <a:txBody>
-                    <a:bodyPr/>
-                    <a:lstStyle/>
-                    <a:p>
-                      <a:pPr marL="0" indent="0" algn="ctr">
-                        <a:buNone/>
-                      </a:pPr>
-                      <a:r>
-                        <a:rPr lang="en-US" sz="1150" dirty="0">
-                          <a:solidFill>
-                            <a:srgbClr val="5B5F7B"/>
-                          </a:solidFill>
-                        </a:rPr>
-                        <a:t>N/A</a:t>
-                      </a:r>
-                      <a:endParaRPr lang="en-US" sz="1150" dirty="0"/>
-                    </a:p>
-                  </a:txBody>
-                  <a:tcPr anchor="ctr">
-                    <a:lnL w="9525" cap="flat" cmpd="sng" algn="ctr">
-                      <a:solidFill>
-                        <a:srgbClr val="D8DAE8"/>
-                      </a:solidFill>
-                      <a:prstDash val="solid"/>
-                      <a:round/>
-                      <a:headEnd type="none" w="med" len="med"/>
-                      <a:tailEnd type="none" w="med" len="med"/>
-                    </a:lnL>
-                    <a:lnR w="9525" cap="flat" cmpd="sng" algn="ctr">
-                      <a:solidFill>
-                        <a:srgbClr val="D8DAE8"/>
-                      </a:solidFill>
-                      <a:prstDash val="solid"/>
-                      <a:round/>
-                      <a:headEnd type="none" w="med" len="med"/>
-                      <a:tailEnd type="none" w="med" len="med"/>
-                    </a:lnR>
-                    <a:lnT w="9525" cap="flat" cmpd="sng" algn="ctr">
-                      <a:solidFill>
-                        <a:srgbClr val="D8DAE8"/>
-                      </a:solidFill>
-                      <a:prstDash val="solid"/>
-                      <a:round/>
-                      <a:headEnd type="none" w="med" len="med"/>
-                      <a:tailEnd type="none" w="med" len="med"/>
-                    </a:lnT>
-                    <a:lnB w="9525" cap="flat" cmpd="sng" algn="ctr">
-                      <a:solidFill>
-                        <a:srgbClr val="D8DAE8"/>
-                      </a:solidFill>
-                      <a:prstDash val="solid"/>
-                      <a:round/>
-                      <a:headEnd type="none" w="med" len="med"/>
-                      <a:tailEnd type="none" w="med" len="med"/>
-                    </a:lnB>
-                  </a:tcPr>
-                </a:tc>
-                <a:tc>
-                  <a:txBody>
-                    <a:bodyPr/>
-                    <a:lstStyle/>
-                    <a:p>
-                      <a:pPr marL="0" indent="0" algn="ctr">
-                        <a:buNone/>
-                      </a:pPr>
-                      <a:r>
-                        <a:rPr lang="en-US" sz="1150" b="1" dirty="0">
-                          <a:solidFill>
-                            <a:srgbClr val="3FA796"/>
-                          </a:solidFill>
-                        </a:rPr>
-                        <a:t>Yes (data only)</a:t>
-                      </a:r>
-                      <a:endParaRPr lang="en-US" sz="1150" dirty="0"/>
-                    </a:p>
-                  </a:txBody>
-                  <a:tcPr anchor="ctr">
-                    <a:lnL w="9525" cap="flat" cmpd="sng" algn="ctr">
-                      <a:solidFill>
-                        <a:srgbClr val="D8DAE8"/>
-                      </a:solidFill>
-                      <a:prstDash val="solid"/>
-                      <a:round/>
-                      <a:headEnd type="none" w="med" len="med"/>
-                      <a:tailEnd type="none" w="med" len="med"/>
-                    </a:lnL>
-                    <a:lnR w="9525" cap="flat" cmpd="sng" algn="ctr">
-                      <a:solidFill>
-                        <a:srgbClr val="D8DAE8"/>
-                      </a:solidFill>
-                      <a:prstDash val="solid"/>
-                      <a:round/>
-                      <a:headEnd type="none" w="med" len="med"/>
-                      <a:tailEnd type="none" w="med" len="med"/>
-                    </a:lnR>
-                    <a:lnT w="9525" cap="flat" cmpd="sng" algn="ctr">
-                      <a:solidFill>
-                        <a:srgbClr val="D8DAE8"/>
-                      </a:solidFill>
-                      <a:prstDash val="solid"/>
-                      <a:round/>
-                      <a:headEnd type="none" w="med" len="med"/>
-                      <a:tailEnd type="none" w="med" len="med"/>
-                    </a:lnT>
-                    <a:lnB w="9525" cap="flat" cmpd="sng" algn="ctr">
-                      <a:solidFill>
-                        <a:srgbClr val="D8DAE8"/>
-                      </a:solidFill>
-                      <a:prstDash val="solid"/>
-                      <a:round/>
-                      <a:headEnd type="none" w="med" len="med"/>
-                      <a:tailEnd type="none" w="med" len="med"/>
-                    </a:lnB>
-                  </a:tcPr>
-                </a:tc>
-                <a:tc>
-                  <a:txBody>
-                    <a:bodyPr/>
-                    <a:lstStyle/>
-                    <a:p>
-                      <a:pPr marL="0" indent="0" algn="ctr">
-                        <a:buNone/>
-                      </a:pPr>
-                      <a:r>
-                        <a:rPr lang="en-US" sz="1150" dirty="0">
-                          <a:solidFill>
-                            <a:srgbClr val="5B5F7B"/>
-                          </a:solidFill>
-                        </a:rPr>
-                        <a:t>N/A</a:t>
-                      </a:r>
-                      <a:endParaRPr lang="en-US" sz="1150" dirty="0"/>
-                    </a:p>
-                  </a:txBody>
-                  <a:tcPr anchor="ctr">
-                    <a:lnL w="9525" cap="flat" cmpd="sng" algn="ctr">
-                      <a:solidFill>
-                        <a:srgbClr val="D8DAE8"/>
-                      </a:solidFill>
-                      <a:prstDash val="solid"/>
-                      <a:round/>
-                      <a:headEnd type="none" w="med" len="med"/>
-                      <a:tailEnd type="none" w="med" len="med"/>
-                    </a:lnL>
-                    <a:lnR w="9525" cap="flat" cmpd="sng" algn="ctr">
-                      <a:solidFill>
-                        <a:srgbClr val="D8DAE8"/>
-                      </a:solidFill>
-                      <a:prstDash val="solid"/>
-                      <a:round/>
-                      <a:headEnd type="none" w="med" len="med"/>
-                      <a:tailEnd type="none" w="med" len="med"/>
-                    </a:lnR>
-                    <a:lnT w="9525" cap="flat" cmpd="sng" algn="ctr">
-                      <a:solidFill>
-                        <a:srgbClr val="D8DAE8"/>
-                      </a:solidFill>
-                      <a:prstDash val="solid"/>
-                      <a:round/>
-                      <a:headEnd type="none" w="med" len="med"/>
-                      <a:tailEnd type="none" w="med" len="med"/>
-                    </a:lnT>
-                    <a:lnB w="9525" cap="flat" cmpd="sng" algn="ctr">
-                      <a:solidFill>
-                        <a:srgbClr val="D8DAE8"/>
-                      </a:solidFill>
-                      <a:prstDash val="solid"/>
-                      <a:round/>
-                      <a:headEnd type="none" w="med" len="med"/>
-                      <a:tailEnd type="none" w="med" len="med"/>
-                    </a:lnB>
-                  </a:tcPr>
-                </a:tc>
-                <a:extLst>
-                  <a:ext uri="{0D108BD9-81ED-4DB2-BD59-A6C34878D82A}">
-                    <a16:rowId xmlns:a16="http://schemas.microsoft.com/office/drawing/2014/main" val="10003"/>
-                  </a:ext>
-                </a:extLst>
-              </a:tr>
-              <a:tr h="777240">
-                <a:tc>
-                  <a:txBody>
-                    <a:bodyPr/>
-                    <a:lstStyle/>
-                    <a:p>
-                      <a:pPr marL="0" indent="0">
-                        <a:buNone/>
-                      </a:pPr>
-                      <a:r>
                         <a:rPr lang="en-US" sz="1200" b="1" dirty="0">
                           <a:solidFill>
                             <a:srgbClr val="FFFFFF"/>
@@ -5139,6 +4865,89 @@
           </a:graphicData>
         </a:graphic>
       </p:graphicFrame>
+      <p:sp>
+        <p:nvSpPr>
+          <p:cNvPr id="6" name="Shape 3"/>
+          <p:cNvSpPr/>
+          <p:nvPr/>
+        </p:nvSpPr>
+        <p:spPr>
+          <a:xfrm>
+            <a:off x="548640" y="4709160"/>
+            <a:ext cx="11064240" cy="685800"/>
+          </a:xfrm>
+          <a:prstGeom prst="roundRect">
+            <a:avLst>
+              <a:gd name="adj" fmla="val 8000"/>
+            </a:avLst>
+          </a:prstGeom>
+          <a:solidFill>
+            <a:srgbClr val="F1F1F8"/>
+          </a:solidFill>
+          <a:ln/>
+        </p:spPr>
+      </p:sp>
+      <p:sp>
+        <p:nvSpPr>
+          <p:cNvPr id="7" name="Text 3"/>
+          <p:cNvSpPr/>
+          <p:nvPr/>
+        </p:nvSpPr>
+        <p:spPr>
+          <a:xfrm>
+            <a:off x="731520" y="4709160"/>
+            <a:ext cx="10698480" cy="685800"/>
+          </a:xfrm>
+          <a:prstGeom prst="rect">
+            <a:avLst/>
+          </a:prstGeom>
+          <a:noFill/>
+          <a:ln/>
+        </p:spPr>
+        <p:txBody>
+          <a:bodyPr wrap="square" lIns="0" tIns="0" rIns="0" bIns="0" rtlCol="0" anchor="ctr"/>
+          <a:lstStyle/>
+          <a:p>
+            <a:pPr marL="0" indent="0">
+              <a:buNone/>
+            </a:pPr>
+            <a:r>
+              <a:rPr lang="en-US" sz="1150" b="1" dirty="0">
+                <a:solidFill>
+                  <a:srgbClr val="1B1F3B"/>
+                </a:solidFill>
+                <a:latin typeface="Calibri" pitchFamily="34" charset="0"/>
+                <a:ea typeface="Calibri" pitchFamily="34" charset="-122"/>
+                <a:cs typeface="Calibri" pitchFamily="34" charset="-120"/>
+              </a:rPr>
+              <a:t>IndicQA Benchmark (Singh et al. 2024): </a:t>
+            </a:r>
+            <a:r>
+              <a:rPr lang="en-US" sz="1150" i="1" dirty="0">
+                <a:solidFill>
+                  <a:srgbClr val="5B5F7B"/>
+                </a:solidFill>
+                <a:latin typeface="Calibri" pitchFamily="34" charset="0"/>
+                <a:ea typeface="Calibri" pitchFamily="34" charset="-122"/>
+                <a:cs typeface="Calibri" pitchFamily="34" charset="-120"/>
+              </a:rPr>
+              <a:t>the 11-language Indic QA evaluation suite used to test every approach above — a </a:t>
+            </a:r>
+            <a:r>
+              <a:rPr lang="en-US" sz="1150" i="1">
+                <a:solidFill>
+                  <a:srgbClr val="5B5F7B"/>
+                </a:solidFill>
+                <a:latin typeface="Calibri" pitchFamily="34" charset="0"/>
+                <a:ea typeface="Calibri" pitchFamily="34" charset="-122"/>
+                <a:cs typeface="Calibri" pitchFamily="34" charset="-120"/>
+              </a:rPr>
+              <a:t>benchmark dataset</a:t>
+            </a:r>
+            <a:endParaRPr lang="en-US" sz="1150" dirty="0"/>
+          </a:p>
+        </p:txBody>
+      </p:sp>
       <p:sp>
         <p:nvSpPr>
           <p:cNvPr id="4" name="Text 2"/>

</xml_diff>